<commit_message>
Update product presentation slides deck with the new AI & Machine Learning features details
</commit_message>
<xml_diff>
--- a/presentation/ExpenseTracker_Product_Presentation.pptx
+++ b/presentation/ExpenseTracker_Product_Presentation.pptx
@@ -15,6 +15,8 @@
     <p:sldId id="263" r:id="rId14"/>
     <p:sldId id="264" r:id="rId15"/>
     <p:sldId id="265" r:id="rId16"/>
+    <p:sldId id="266" r:id="rId17"/>
+    <p:sldId id="267" r:id="rId18"/>
   </p:sldIdLst>
   <p:sldSz cx="12191695" cy="6858000" type="screen4x3"/>
   <p:notesSz cx="6858000" cy="9144000"/>
@@ -3435,55 +3437,449 @@
               </a:defRPr>
             </a:pPr>
             <a:r>
-              <a:t>Future Project Roadmap</a:t>
-            </a:r>
-          </a:p>
-          <a:p>
-            <a:pPr>
-              <a:spcAft>
-                <a:spcPts val="1000"/>
-              </a:spcAft>
-              <a:defRPr sz="1150">
+              <a:rPr sz="1600" b="1">
+                <a:solidFill>
+                  <a:srgbClr val="10B981"/>
+                </a:solidFill>
+                <a:latin typeface="Arial"/>
+              </a:rPr>
+              <a:t>Completed AI Features
+</a:t>
+            </a:r>
+          </a:p>
+          <a:p>
+            <a:pPr>
+              <a:spcBef>
+                <a:spcPts val="600"/>
+              </a:spcBef>
+            </a:pPr>
+            <a:r>
+              <a:rPr sz="1300">
                 <a:solidFill>
                   <a:srgbClr val="64748B"/>
                 </a:solidFill>
-                <a:latin typeface="Inter"/>
-              </a:defRPr>
-            </a:pPr>
-            <a:r>
-              <a:t>★  AI-Powered Audits: Automatic categorization of uploaded receipts via OCR image text analysis.</a:t>
-            </a:r>
-          </a:p>
-          <a:p>
-            <a:pPr>
-              <a:spcAft>
-                <a:spcPts val="1000"/>
-              </a:spcAft>
-              <a:defRPr sz="1150">
+                <a:latin typeface="Calibri"/>
+              </a:rPr>
+              <a:t>▪  Smart Categorization: TF-IDF vectorization with Multinomial Naive Bayes categorizer pipeline.</a:t>
+            </a:r>
+          </a:p>
+          <a:p>
+            <a:pPr>
+              <a:spcBef>
+                <a:spcPts val="600"/>
+              </a:spcBef>
+            </a:pPr>
+            <a:r>
+              <a:rPr sz="1300">
                 <a:solidFill>
                   <a:srgbClr val="64748B"/>
                 </a:solidFill>
-                <a:latin typeface="Inter"/>
-              </a:defRPr>
-            </a:pPr>
-            <a:r>
-              <a:t>★  Bank Sync Integration: Automatic feeds loading transactions safely via secure Open Banking APIs.</a:t>
-            </a:r>
-          </a:p>
-          <a:p>
-            <a:pPr>
-              <a:spcAft>
-                <a:spcPts val="1000"/>
-              </a:spcAft>
-              <a:defRPr sz="1150">
+                <a:latin typeface="Calibri"/>
+              </a:rPr>
+              <a:t>▪  AI Vision Receipt Scanning: Multimodal layout recognition extracting amounts, categories, and merchants.</a:t>
+            </a:r>
+          </a:p>
+          <a:p>
+            <a:pPr>
+              <a:spcBef>
+                <a:spcPts val="600"/>
+              </a:spcBef>
+            </a:pPr>
+            <a:r>
+              <a:rPr sz="1300">
                 <a:solidFill>
                   <a:srgbClr val="64748B"/>
                 </a:solidFill>
-                <a:latin typeface="Inter"/>
-              </a:defRPr>
-            </a:pPr>
-            <a:r>
-              <a:t>★  Predictive Alerts: AI models forecasting cashflow changes and warning of potential budget breaches in advance.</a:t>
+                <a:latin typeface="Calibri"/>
+              </a:rPr>
+              <a:t>▪  Predictive Spends Forecasting: Linear Regression predicting cumulative trends over active calendar months.</a:t>
+            </a:r>
+          </a:p>
+          <a:p>
+            <a:pPr>
+              <a:spcBef>
+                <a:spcPts val="1400"/>
+              </a:spcBef>
+            </a:pPr>
+            <a:r>
+              <a:rPr sz="1600" b="1">
+                <a:solidFill>
+                  <a:srgbClr val="4F46E5"/>
+                </a:solidFill>
+                <a:latin typeface="Arial"/>
+              </a:rPr>
+              <a:t>Future Project Roadmap
+</a:t>
+            </a:r>
+          </a:p>
+          <a:p>
+            <a:pPr>
+              <a:spcBef>
+                <a:spcPts val="600"/>
+              </a:spcBef>
+            </a:pPr>
+            <a:r>
+              <a:rPr sz="1300">
+                <a:solidFill>
+                  <a:srgbClr val="64748B"/>
+                </a:solidFill>
+                <a:latin typeface="Calibri"/>
+              </a:rPr>
+              <a:t>▪  Open Banking Sync: Secure bank feeds integration to automate ledger reconciliation.</a:t>
+            </a:r>
+          </a:p>
+          <a:p>
+            <a:pPr>
+              <a:spcBef>
+                <a:spcPts val="600"/>
+              </a:spcBef>
+            </a:pPr>
+            <a:r>
+              <a:rPr sz="1300">
+                <a:solidFill>
+                  <a:srgbClr val="64748B"/>
+                </a:solidFill>
+                <a:latin typeface="Calibri"/>
+              </a:rPr>
+              <a:t>▪  Multi-Currency Conversions: Dynamic currency cross-rates mapping.</a:t>
+            </a:r>
+          </a:p>
+          <a:p>
+            <a:pPr>
+              <a:spcBef>
+                <a:spcPts val="600"/>
+              </a:spcBef>
+            </a:pPr>
+            <a:r>
+              <a:rPr sz="1300">
+                <a:solidFill>
+                  <a:srgbClr val="64748B"/>
+                </a:solidFill>
+                <a:latin typeface="Calibri"/>
+              </a:rPr>
+              <a:t>▪  Voice-Enabled Audits: Speech-to-text recording controls.</a:t>
+            </a:r>
+          </a:p>
+        </p:txBody>
+      </p:sp>
+    </p:spTree>
+  </p:cSld>
+  <p:clrMapOvr>
+    <a:masterClrMapping/>
+  </p:clrMapOvr>
+</p:sld>
+</file>
+
+<file path=ppt/slides/slide11.xml><?xml version="1.0" encoding="utf-8"?>
+<p:sld xmlns:a="http://schemas.openxmlformats.org/drawingml/2006/main" xmlns:p="http://schemas.openxmlformats.org/presentationml/2006/main" xmlns:r="http://schemas.openxmlformats.org/officeDocument/2006/relationships">
+  <p:cSld>
+    <p:spTree>
+      <p:nvGrpSpPr>
+        <p:cNvPr id="1" name=""/>
+        <p:cNvGrpSpPr/>
+        <p:nvPr/>
+      </p:nvGrpSpPr>
+      <p:grpSpPr/>
+      <p:sp>
+        <p:nvSpPr>
+          <p:cNvPr id="2" name="TextBox 1"/>
+          <p:cNvSpPr txBox="1"/>
+          <p:nvPr/>
+        </p:nvSpPr>
+        <p:spPr>
+          <a:xfrm>
+            <a:off x="731520" y="457200"/>
+            <a:ext cx="10698480" cy="1097280"/>
+          </a:xfrm>
+          <a:prstGeom prst="rect">
+            <a:avLst/>
+          </a:prstGeom>
+          <a:noFill/>
+        </p:spPr>
+        <p:txBody>
+          <a:bodyPr wrap="square">
+            <a:spAutoFit/>
+          </a:bodyPr>
+          <a:lstStyle/>
+          <a:p>
+            <a:r>
+              <a:rPr sz="2800" b="1">
+                <a:solidFill>
+                  <a:srgbClr val="0F172A"/>
+                </a:solidFill>
+                <a:latin typeface="Arial"/>
+              </a:rPr>
+              <a:t>10. AI &amp; MACHINE LEARNING SUITE</a:t>
+            </a:r>
+          </a:p>
+          <a:p>
+            <a:r>
+              <a:rPr sz="1400">
+                <a:solidFill>
+                  <a:srgbClr val="4F46E5"/>
+                </a:solidFill>
+                <a:latin typeface="Arial"/>
+              </a:rPr>
+              <a:t>Deterministic Models &amp; Predictive Intelligence</a:t>
+            </a:r>
+          </a:p>
+        </p:txBody>
+      </p:sp>
+      <p:sp>
+        <p:nvSpPr>
+          <p:cNvPr id="3" name="TextBox 2"/>
+          <p:cNvSpPr txBox="1"/>
+          <p:nvPr/>
+        </p:nvSpPr>
+        <p:spPr>
+          <a:xfrm>
+            <a:off x="731520" y="1828800"/>
+            <a:ext cx="10698480" cy="4114800"/>
+          </a:xfrm>
+          <a:prstGeom prst="rect">
+            <a:avLst/>
+          </a:prstGeom>
+          <a:noFill/>
+        </p:spPr>
+        <p:txBody>
+          <a:bodyPr wrap="square">
+            <a:spAutoFit/>
+          </a:bodyPr>
+          <a:lstStyle/>
+          <a:p>
+            <a:pPr>
+              <a:spcBef>
+                <a:spcPts val="0"/>
+              </a:spcBef>
+            </a:pPr>
+            <a:r>
+              <a:rPr sz="1500" b="1">
+                <a:solidFill>
+                  <a:srgbClr val="1E293B"/>
+                </a:solidFill>
+                <a:latin typeface="Arial"/>
+              </a:rPr>
+              <a:t>▪  Smart Categorization Pipeline (scikit-learn): </a:t>
+            </a:r>
+            <a:r>
+              <a:rPr sz="1400">
+                <a:solidFill>
+                  <a:srgbClr val="475569"/>
+                </a:solidFill>
+                <a:latin typeface="Calibri"/>
+              </a:rPr>
+              <a:t>Uses TF-IDF Vectorization mapping ledger descriptions into features, running a Multinomial Naive Bayes classification model to automatically output predicted transaction categories (e.g. food, bills) with local millisecond latency.</a:t>
+            </a:r>
+          </a:p>
+          <a:p>
+            <a:pPr>
+              <a:spcBef>
+                <a:spcPts val="1200"/>
+              </a:spcBef>
+            </a:pPr>
+            <a:r>
+              <a:rPr sz="1500" b="1">
+                <a:solidFill>
+                  <a:srgbClr val="1E293B"/>
+                </a:solidFill>
+                <a:latin typeface="Arial"/>
+              </a:rPr>
+              <a:t>▪  Spends Cumulative Forecaster (scikit-learn): </a:t>
+            </a:r>
+            <a:r>
+              <a:rPr sz="1400">
+                <a:solidFill>
+                  <a:srgbClr val="475569"/>
+                </a:solidFill>
+                <a:latin typeface="Calibri"/>
+              </a:rPr>
+              <a:t>Fits a local Linear Regression model against cumulative daily expenses in the current month to compute velocity runs, rendering predicted cumulative budget trajectories on your chart.</a:t>
+            </a:r>
+          </a:p>
+          <a:p>
+            <a:pPr>
+              <a:spcBef>
+                <a:spcPts val="1200"/>
+              </a:spcBef>
+            </a:pPr>
+            <a:r>
+              <a:rPr sz="1500" b="1">
+                <a:solidFill>
+                  <a:srgbClr val="1E293B"/>
+                </a:solidFill>
+                <a:latin typeface="Arial"/>
+              </a:rPr>
+              <a:t>▪  Multimodal Receipt Intelligence (Gemini API): </a:t>
+            </a:r>
+            <a:r>
+              <a:rPr sz="1400">
+                <a:solidFill>
+                  <a:srgbClr val="475569"/>
+                </a:solidFill>
+                <a:latin typeface="Calibri"/>
+              </a:rPr>
+              <a:t>Integrates Gemini 1.5 Flash to visually process receipts and extract raw data properties (merchant, amount, category, date) into JSON parameters directly in transaction fields.</a:t>
+            </a:r>
+          </a:p>
+        </p:txBody>
+      </p:sp>
+    </p:spTree>
+  </p:cSld>
+  <p:clrMapOvr>
+    <a:masterClrMapping/>
+  </p:clrMapOvr>
+</p:sld>
+</file>
+
+<file path=ppt/slides/slide12.xml><?xml version="1.0" encoding="utf-8"?>
+<p:sld xmlns:a="http://schemas.openxmlformats.org/drawingml/2006/main" xmlns:p="http://schemas.openxmlformats.org/presentationml/2006/main" xmlns:r="http://schemas.openxmlformats.org/officeDocument/2006/relationships">
+  <p:cSld>
+    <p:spTree>
+      <p:nvGrpSpPr>
+        <p:cNvPr id="1" name=""/>
+        <p:cNvGrpSpPr/>
+        <p:nvPr/>
+      </p:nvGrpSpPr>
+      <p:grpSpPr/>
+      <p:sp>
+        <p:nvSpPr>
+          <p:cNvPr id="2" name="TextBox 1"/>
+          <p:cNvSpPr txBox="1"/>
+          <p:nvPr/>
+        </p:nvSpPr>
+        <p:spPr>
+          <a:xfrm>
+            <a:off x="731520" y="457200"/>
+            <a:ext cx="10698480" cy="1097280"/>
+          </a:xfrm>
+          <a:prstGeom prst="rect">
+            <a:avLst/>
+          </a:prstGeom>
+          <a:noFill/>
+        </p:spPr>
+        <p:txBody>
+          <a:bodyPr wrap="square">
+            <a:spAutoFit/>
+          </a:bodyPr>
+          <a:lstStyle/>
+          <a:p>
+            <a:r>
+              <a:rPr sz="2800" b="1">
+                <a:solidFill>
+                  <a:srgbClr val="0F172A"/>
+                </a:solidFill>
+                <a:latin typeface="Arial"/>
+              </a:rPr>
+              <a:t>11. CONVERSATIONAL EXPENSO AI</a:t>
+            </a:r>
+          </a:p>
+          <a:p>
+            <a:r>
+              <a:rPr sz="1400">
+                <a:solidFill>
+                  <a:srgbClr val="4F46E5"/>
+                </a:solidFill>
+                <a:latin typeface="Arial"/>
+              </a:rPr>
+              <a:t>Contextual Prompts &amp; Dual-Engine Chat Assistant</a:t>
+            </a:r>
+          </a:p>
+        </p:txBody>
+      </p:sp>
+      <p:sp>
+        <p:nvSpPr>
+          <p:cNvPr id="3" name="TextBox 2"/>
+          <p:cNvSpPr txBox="1"/>
+          <p:nvPr/>
+        </p:nvSpPr>
+        <p:spPr>
+          <a:xfrm>
+            <a:off x="731520" y="1828800"/>
+            <a:ext cx="10698480" cy="4114800"/>
+          </a:xfrm>
+          <a:prstGeom prst="rect">
+            <a:avLst/>
+          </a:prstGeom>
+          <a:noFill/>
+        </p:spPr>
+        <p:txBody>
+          <a:bodyPr wrap="square">
+            <a:spAutoFit/>
+          </a:bodyPr>
+          <a:lstStyle/>
+          <a:p>
+            <a:pPr>
+              <a:spcBef>
+                <a:spcPts val="0"/>
+              </a:spcBef>
+            </a:pPr>
+            <a:r>
+              <a:rPr sz="1500" b="1">
+                <a:solidFill>
+                  <a:srgbClr val="1E293B"/>
+                </a:solidFill>
+                <a:latin typeface="Arial"/>
+              </a:rPr>
+              <a:t>▪  Contextual Prompt Injections: </a:t>
+            </a:r>
+            <a:r>
+              <a:rPr sz="1400">
+                <a:solidFill>
+                  <a:srgbClr val="475569"/>
+                </a:solidFill>
+                <a:latin typeface="Calibri"/>
+              </a:rPr>
+              <a:t>Compiles comprehensive JSON summaries containing monthly income sheets, expenses ratios, settings preferences, category configurations, and last transactions into prompt contexts.</a:t>
+            </a:r>
+          </a:p>
+          <a:p>
+            <a:pPr>
+              <a:spcBef>
+                <a:spcPts val="1200"/>
+              </a:spcBef>
+            </a:pPr>
+            <a:r>
+              <a:rPr sz="1500" b="1">
+                <a:solidFill>
+                  <a:srgbClr val="1E293B"/>
+                </a:solidFill>
+                <a:latin typeface="Arial"/>
+              </a:rPr>
+              <a:t>▪  Generative Assistant Engine (Gemini 1.5 Flash): </a:t>
+            </a:r>
+            <a:r>
+              <a:rPr sz="1400">
+                <a:solidFill>
+                  <a:srgbClr val="475569"/>
+                </a:solidFill>
+                <a:latin typeface="Calibri"/>
+              </a:rPr>
+              <a:t>Feeds user messages and rich context data to Gemini to return personalized financial recommendations, budget analyses, and savings advisories.</a:t>
+            </a:r>
+          </a:p>
+          <a:p>
+            <a:pPr>
+              <a:spcBef>
+                <a:spcPts val="1200"/>
+              </a:spcBef>
+            </a:pPr>
+            <a:r>
+              <a:rPr sz="1500" b="1">
+                <a:solidFill>
+                  <a:srgbClr val="1E293B"/>
+                </a:solidFill>
+                <a:latin typeface="Arial"/>
+              </a:rPr>
+              <a:t>▪  Graceful Local Fallbacks: </a:t>
+            </a:r>
+            <a:r>
+              <a:rPr sz="1400">
+                <a:solidFill>
+                  <a:srgbClr val="475569"/>
+                </a:solidFill>
+                <a:latin typeface="Calibri"/>
+              </a:rPr>
+              <a:t>Maintains dual-engine compatibility: if no Gemini API Key is configured, the assistant switches to local rule-based keyword scanning to guarantee complete offline execution without server failures.</a:t>
             </a:r>
           </a:p>
         </p:txBody>

</xml_diff>